<commit_message>
Redesign Data Sharing one-pager as Deloitte-branded editorial slide
Replaces the fully-custom navy/amber/teal design with the Deloitte
brand palette (black background, green/deep-green accents) used
throughout the other Fraud in 2026 decks. Leads with a new framing
insight -- structural barriers average 70% vs. internal barriers'
30% -- rather than restating the individual barrier percentages,
then shows how the top two requested fixes mirror the structural
barriers, and closes with the three regional/sector nuances as
short bullet call-outs.

Co-Authored-By: Claude Sonnet 5 <noreply@anthropic.com>
Claude-Session: https://claude.ai/code/session_01F6YKjZtdH33RrHLpCiLALg
</commit_message>
<xml_diff>
--- a/Visual Story One-Pagers.pptx
+++ b/Visual Story One-Pagers.pptx
@@ -857,7 +857,7 @@
     <p:bg>
       <p:bgPr>
         <a:solidFill>
-          <a:srgbClr val="0B1220"/>
+          <a:srgbClr val="050607"/>
         </a:solidFill>
       </p:bgPr>
     </p:bg>
@@ -883,8 +883,8 @@
         </p:nvSpPr>
         <p:spPr>
           <a:xfrm>
-            <a:off x="548640" y="384048"/>
-            <a:ext cx="11094415" cy="256032"/>
+            <a:off x="548640" y="365760"/>
+            <a:ext cx="11094415" cy="219456"/>
           </a:xfrm>
           <a:prstGeom prst="rect">
             <a:avLst/>
@@ -900,17 +900,17 @@
               <a:buNone/>
             </a:pPr>
             <a:r>
-              <a:rPr lang="en-US" sz="1100" b="1" spc="200" kern="0" dirty="0">
+              <a:rPr lang="en-US" sz="1050" b="1" spc="150" kern="0" dirty="0">
                 <a:solidFill>
-                  <a:srgbClr val="3FC1C9"/>
+                  <a:srgbClr val="86BC25"/>
                 </a:solidFill>
                 <a:latin typeface="Calibri" pitchFamily="34" charset="0"/>
                 <a:ea typeface="Calibri" pitchFamily="34" charset="-122"/>
                 <a:cs typeface="Calibri" pitchFamily="34" charset="-120"/>
               </a:rPr>
-              <a:t>FRAUD IN 2026  ·  INFORMATION SHARING</a:t>
-            </a:r>
-            <a:endParaRPr lang="en-US" sz="1100" dirty="0"/>
+              <a:t>INFORMATION SHARING   ·   Q4 &amp; Q5   ·   n=100</a:t>
+            </a:r>
+            <a:endParaRPr lang="en-US" sz="1050" dirty="0"/>
           </a:p>
         </p:txBody>
       </p:sp>
@@ -922,232 +922,8 @@
         </p:nvSpPr>
         <p:spPr>
           <a:xfrm>
-            <a:off x="548640" y="658368"/>
-            <a:ext cx="11094415" cy="658368"/>
-          </a:xfrm>
-          <a:prstGeom prst="rect">
-            <a:avLst/>
-          </a:prstGeom>
-          <a:noFill/>
-          <a:ln/>
-        </p:spPr>
-        <p:txBody>
-          <a:bodyPr wrap="square" lIns="0" tIns="0" rIns="0" bIns="0" rtlCol="0" anchor="t"/>
-          <a:lstStyle/>
-          <a:p>
-            <a:pPr algn="l" indent="0" marL="0">
-              <a:buNone/>
-            </a:pPr>
-            <a:r>
-              <a:rPr lang="en-US" sz="3800" b="1" dirty="0">
-                <a:solidFill>
-                  <a:srgbClr val="F5F1E8"/>
-                </a:solidFill>
-                <a:latin typeface="Georgia" pitchFamily="34" charset="0"/>
-                <a:ea typeface="Georgia" pitchFamily="34" charset="-122"/>
-                <a:cs typeface="Georgia" pitchFamily="34" charset="-120"/>
-              </a:rPr>
-              <a:t>Enablement, Not Encouragement</a:t>
-            </a:r>
-            <a:endParaRPr lang="en-US" sz="3800" dirty="0"/>
-          </a:p>
-        </p:txBody>
-      </p:sp>
-      <p:sp>
-        <p:nvSpPr>
-          <p:cNvPr id="4" name="Text 2"/>
-          <p:cNvSpPr txBox="1"/>
-          <p:nvPr/>
-        </p:nvSpPr>
-        <p:spPr>
-          <a:xfrm>
-            <a:off x="548640" y="1335024"/>
-            <a:ext cx="11094415" cy="310896"/>
-          </a:xfrm>
-          <a:prstGeom prst="rect">
-            <a:avLst/>
-          </a:prstGeom>
-          <a:noFill/>
-          <a:ln/>
-        </p:spPr>
-        <p:txBody>
-          <a:bodyPr wrap="square" lIns="0" tIns="0" rIns="0" bIns="0" rtlCol="0" anchor="t"/>
-          <a:lstStyle/>
-          <a:p>
-            <a:pPr algn="l" indent="0" marL="0">
-              <a:buNone/>
-            </a:pPr>
-            <a:r>
-              <a:rPr lang="en-US" sz="1350" i="1" dirty="0">
-                <a:solidFill>
-                  <a:srgbClr val="9AA5B1"/>
-                </a:solidFill>
-                <a:latin typeface="Calibri" pitchFamily="34" charset="0"/>
-                <a:ea typeface="Calibri" pitchFamily="34" charset="-122"/>
-                <a:cs typeface="Calibri" pitchFamily="34" charset="-120"/>
-              </a:rPr>
-              <a:t>Fraud leaders agree on what's broken — and increasingly, on what would fix it.</a:t>
-            </a:r>
-            <a:endParaRPr lang="en-US" sz="1350" dirty="0"/>
-          </a:p>
-        </p:txBody>
-      </p:sp>
-      <p:sp>
-        <p:nvSpPr>
-          <p:cNvPr id="5" name="Shape 3"/>
-          <p:cNvSpPr/>
-          <p:nvPr/>
-        </p:nvSpPr>
-        <p:spPr>
-          <a:xfrm>
-            <a:off x="548640" y="1755648"/>
-            <a:ext cx="11094415" cy="0"/>
-          </a:xfrm>
-          <a:prstGeom prst="line">
-            <a:avLst/>
-          </a:prstGeom>
-          <a:noFill/>
-          <a:ln w="12700">
-            <a:solidFill>
-              <a:srgbClr val="263248"/>
-            </a:solidFill>
-            <a:prstDash val="solid"/>
-          </a:ln>
-        </p:spPr>
-      </p:sp>
-      <p:sp>
-        <p:nvSpPr>
-          <p:cNvPr id="6" name="Shape 4"/>
-          <p:cNvSpPr/>
-          <p:nvPr/>
-        </p:nvSpPr>
-        <p:spPr>
-          <a:xfrm>
-            <a:off x="6095848" y="1956816"/>
-            <a:ext cx="0" cy="4315968"/>
-          </a:xfrm>
-          <a:prstGeom prst="line">
-            <a:avLst/>
-          </a:prstGeom>
-          <a:noFill/>
-          <a:ln w="12700">
-            <a:solidFill>
-              <a:srgbClr val="263248"/>
-            </a:solidFill>
-            <a:prstDash val="solid"/>
-          </a:ln>
-        </p:spPr>
-      </p:sp>
-      <p:sp>
-        <p:nvSpPr>
-          <p:cNvPr id="7" name="Shape 5"/>
-          <p:cNvSpPr/>
-          <p:nvPr/>
-        </p:nvSpPr>
-        <p:spPr>
-          <a:xfrm>
-            <a:off x="548640" y="1956816"/>
-            <a:ext cx="1737360" cy="292608"/>
-          </a:xfrm>
-          <a:prstGeom prst="roundRect">
-            <a:avLst>
-              <a:gd name="adj" fmla="val 50000"/>
-            </a:avLst>
-          </a:prstGeom>
-          <a:solidFill>
-            <a:srgbClr val="E8935A"/>
-          </a:solidFill>
-          <a:ln/>
-        </p:spPr>
-      </p:sp>
-      <p:sp>
-        <p:nvSpPr>
-          <p:cNvPr id="8" name="Text 6"/>
-          <p:cNvSpPr txBox="1"/>
-          <p:nvPr/>
-        </p:nvSpPr>
-        <p:spPr>
-          <a:xfrm>
-            <a:off x="548640" y="1956816"/>
-            <a:ext cx="1737360" cy="292608"/>
-          </a:xfrm>
-          <a:prstGeom prst="rect">
-            <a:avLst/>
-          </a:prstGeom>
-          <a:noFill/>
-          <a:ln/>
-        </p:spPr>
-        <p:txBody>
-          <a:bodyPr wrap="square" lIns="0" tIns="0" rIns="0" bIns="0" rtlCol="0" anchor="ctr"/>
-          <a:lstStyle/>
-          <a:p>
-            <a:pPr algn="ctr" indent="0" marL="0">
-              <a:buNone/>
-            </a:pPr>
-            <a:r>
-              <a:rPr lang="en-US" sz="1050" b="1" spc="100" kern="0" dirty="0">
-                <a:solidFill>
-                  <a:srgbClr val="0B1220"/>
-                </a:solidFill>
-                <a:latin typeface="Calibri" pitchFamily="34" charset="0"/>
-                <a:ea typeface="Calibri" pitchFamily="34" charset="-122"/>
-                <a:cs typeface="Calibri" pitchFamily="34" charset="-120"/>
-              </a:rPr>
-              <a:t>THE BARRIERS</a:t>
-            </a:r>
-            <a:endParaRPr lang="en-US" sz="1050" dirty="0"/>
-          </a:p>
-        </p:txBody>
-      </p:sp>
-      <p:sp>
-        <p:nvSpPr>
-          <p:cNvPr id="9" name="Text 7"/>
-          <p:cNvSpPr txBox="1"/>
-          <p:nvPr/>
-        </p:nvSpPr>
-        <p:spPr>
-          <a:xfrm>
-            <a:off x="548640" y="2340864"/>
-            <a:ext cx="1234440" cy="283464"/>
-          </a:xfrm>
-          <a:prstGeom prst="rect">
-            <a:avLst/>
-          </a:prstGeom>
-          <a:noFill/>
-          <a:ln/>
-        </p:spPr>
-        <p:txBody>
-          <a:bodyPr wrap="square" lIns="0" tIns="0" rIns="0" bIns="0" rtlCol="0" anchor="t"/>
-          <a:lstStyle/>
-          <a:p>
-            <a:pPr algn="l" indent="0" marL="0">
-              <a:buNone/>
-            </a:pPr>
-            <a:r>
-              <a:rPr lang="en-US" sz="3000" b="1" dirty="0">
-                <a:solidFill>
-                  <a:srgbClr val="E8935A"/>
-                </a:solidFill>
-                <a:latin typeface="Georgia" pitchFamily="34" charset="0"/>
-                <a:ea typeface="Georgia" pitchFamily="34" charset="-122"/>
-                <a:cs typeface="Georgia" pitchFamily="34" charset="-120"/>
-              </a:rPr>
-              <a:t>77%</a:t>
-            </a:r>
-            <a:endParaRPr lang="en-US" sz="3000" dirty="0"/>
-          </a:p>
-        </p:txBody>
-      </p:sp>
-      <p:sp>
-        <p:nvSpPr>
-          <p:cNvPr id="10" name="Text 8"/>
-          <p:cNvSpPr txBox="1"/>
-          <p:nvPr/>
-        </p:nvSpPr>
-        <p:spPr>
-          <a:xfrm>
-            <a:off x="1828800" y="2368296"/>
-            <a:ext cx="4015588" cy="283464"/>
+            <a:off x="548640" y="621792"/>
+            <a:ext cx="11094415" cy="841248"/>
           </a:xfrm>
           <a:prstGeom prst="rect">
             <a:avLst/>
@@ -1166,70 +942,53 @@
               <a:buNone/>
             </a:pPr>
             <a:r>
-              <a:rPr lang="en-US" sz="1200" dirty="0">
+              <a:rPr lang="en-US" sz="2700" b="1" dirty="0">
                 <a:solidFill>
-                  <a:srgbClr val="F5F1E8"/>
+                  <a:srgbClr val="FFFFFF"/>
                 </a:solidFill>
                 <a:latin typeface="Calibri" pitchFamily="34" charset="0"/>
                 <a:ea typeface="Calibri" pitchFamily="34" charset="-122"/>
                 <a:cs typeface="Calibri" pitchFamily="34" charset="-120"/>
               </a:rPr>
-              <a:t>Data standardization &amp; quality</a:t>
-            </a:r>
-            <a:endParaRPr lang="en-US" sz="1200" dirty="0"/>
-          </a:p>
-        </p:txBody>
-      </p:sp>
-      <p:sp>
-        <p:nvSpPr>
-          <p:cNvPr id="11" name="Shape 9"/>
+              <a:t>Leaders Already Won the Internal Argument. What's Missing Is the Plumbing.</a:t>
+            </a:r>
+            <a:endParaRPr lang="en-US" sz="2700" dirty="0"/>
+          </a:p>
+        </p:txBody>
+      </p:sp>
+      <p:sp>
+        <p:nvSpPr>
+          <p:cNvPr id="4" name="Shape 2"/>
           <p:cNvSpPr/>
           <p:nvPr/>
         </p:nvSpPr>
         <p:spPr>
           <a:xfrm>
-            <a:off x="548640" y="2651760"/>
-            <a:ext cx="5295748" cy="82296"/>
-          </a:xfrm>
-          <a:prstGeom prst="rect">
-            <a:avLst/>
-          </a:prstGeom>
-          <a:solidFill>
-            <a:srgbClr val="6B4A34"/>
-          </a:solidFill>
-          <a:ln/>
-        </p:spPr>
-      </p:sp>
-      <p:sp>
-        <p:nvSpPr>
-          <p:cNvPr id="12" name="Shape 10"/>
-          <p:cNvSpPr/>
-          <p:nvPr/>
-        </p:nvSpPr>
-        <p:spPr>
-          <a:xfrm>
-            <a:off x="548640" y="2651760"/>
-            <a:ext cx="4077726" cy="82296"/>
-          </a:xfrm>
-          <a:prstGeom prst="rect">
-            <a:avLst/>
-          </a:prstGeom>
-          <a:solidFill>
-            <a:srgbClr val="E8935A"/>
-          </a:solidFill>
-          <a:ln/>
-        </p:spPr>
-      </p:sp>
-      <p:sp>
-        <p:nvSpPr>
-          <p:cNvPr id="13" name="Text 11"/>
+            <a:off x="548640" y="1517904"/>
+            <a:ext cx="11094415" cy="0"/>
+          </a:xfrm>
+          <a:prstGeom prst="line">
+            <a:avLst/>
+          </a:prstGeom>
+          <a:noFill/>
+          <a:ln w="12700">
+            <a:solidFill>
+              <a:srgbClr val="1C2419"/>
+            </a:solidFill>
+            <a:prstDash val="solid"/>
+          </a:ln>
+        </p:spPr>
+      </p:sp>
+      <p:sp>
+        <p:nvSpPr>
+          <p:cNvPr id="5" name="Text 3"/>
           <p:cNvSpPr txBox="1"/>
           <p:nvPr/>
         </p:nvSpPr>
         <p:spPr>
           <a:xfrm>
-            <a:off x="548640" y="2880360"/>
-            <a:ext cx="1234440" cy="283464"/>
+            <a:off x="548640" y="1737360"/>
+            <a:ext cx="5029200" cy="1051560"/>
           </a:xfrm>
           <a:prstGeom prst="rect">
             <a:avLst/>
@@ -1245,151 +1004,30 @@
               <a:buNone/>
             </a:pPr>
             <a:r>
-              <a:rPr lang="en-US" sz="3000" b="1" dirty="0">
+              <a:rPr lang="en-US" sz="6600" b="1" dirty="0">
                 <a:solidFill>
-                  <a:srgbClr val="E8935A"/>
-                </a:solidFill>
-                <a:latin typeface="Georgia" pitchFamily="34" charset="0"/>
-                <a:ea typeface="Georgia" pitchFamily="34" charset="-122"/>
-                <a:cs typeface="Georgia" pitchFamily="34" charset="-120"/>
-              </a:rPr>
-              <a:t>73%</a:t>
-            </a:r>
-            <a:endParaRPr lang="en-US" sz="3000" dirty="0"/>
-          </a:p>
-        </p:txBody>
-      </p:sp>
-      <p:sp>
-        <p:nvSpPr>
-          <p:cNvPr id="14" name="Text 12"/>
-          <p:cNvSpPr txBox="1"/>
-          <p:nvPr/>
-        </p:nvSpPr>
-        <p:spPr>
-          <a:xfrm>
-            <a:off x="1828800" y="2907792"/>
-            <a:ext cx="4015588" cy="283464"/>
-          </a:xfrm>
-          <a:prstGeom prst="rect">
-            <a:avLst/>
-          </a:prstGeom>
-          <a:noFill/>
-          <a:ln/>
-        </p:spPr>
-        <p:txBody>
-          <a:bodyPr wrap="square" lIns="0" tIns="0" rIns="0" bIns="0" rtlCol="0" anchor="t"/>
-          <a:lstStyle/>
-          <a:p>
-            <a:pPr algn="l" indent="0" marL="0">
-              <a:lnSpc>
-                <a:spcPct val="105000"/>
-              </a:lnSpc>
-              <a:buNone/>
-            </a:pPr>
-            <a:r>
-              <a:rPr lang="en-US" sz="1200" dirty="0">
-                <a:solidFill>
-                  <a:srgbClr val="F5F1E8"/>
+                  <a:srgbClr val="86BC25"/>
                 </a:solidFill>
                 <a:latin typeface="Calibri" pitchFamily="34" charset="0"/>
                 <a:ea typeface="Calibri" pitchFamily="34" charset="-122"/>
                 <a:cs typeface="Calibri" pitchFamily="34" charset="-120"/>
               </a:rPr>
-              <a:t>Legal, privacy &amp; regulatory constraints</a:t>
-            </a:r>
-            <a:endParaRPr lang="en-US" sz="1200" dirty="0"/>
-          </a:p>
-        </p:txBody>
-      </p:sp>
-      <p:sp>
-        <p:nvSpPr>
-          <p:cNvPr id="15" name="Shape 13"/>
-          <p:cNvSpPr/>
-          <p:nvPr/>
-        </p:nvSpPr>
-        <p:spPr>
-          <a:xfrm>
-            <a:off x="548640" y="3191256"/>
-            <a:ext cx="5295748" cy="82296"/>
-          </a:xfrm>
-          <a:prstGeom prst="rect">
-            <a:avLst/>
-          </a:prstGeom>
-          <a:solidFill>
-            <a:srgbClr val="6B4A34"/>
-          </a:solidFill>
-          <a:ln/>
-        </p:spPr>
-      </p:sp>
-      <p:sp>
-        <p:nvSpPr>
-          <p:cNvPr id="16" name="Shape 14"/>
-          <p:cNvSpPr/>
-          <p:nvPr/>
-        </p:nvSpPr>
-        <p:spPr>
-          <a:xfrm>
-            <a:off x="548640" y="3191256"/>
-            <a:ext cx="3865896" cy="82296"/>
-          </a:xfrm>
-          <a:prstGeom prst="rect">
-            <a:avLst/>
-          </a:prstGeom>
-          <a:solidFill>
-            <a:srgbClr val="E8935A"/>
-          </a:solidFill>
-          <a:ln/>
-        </p:spPr>
-      </p:sp>
-      <p:sp>
-        <p:nvSpPr>
-          <p:cNvPr id="17" name="Text 15"/>
+              <a:t>70%</a:t>
+            </a:r>
+            <a:endParaRPr lang="en-US" sz="6600" dirty="0"/>
+          </a:p>
+        </p:txBody>
+      </p:sp>
+      <p:sp>
+        <p:nvSpPr>
+          <p:cNvPr id="6" name="Text 4"/>
           <p:cNvSpPr txBox="1"/>
           <p:nvPr/>
         </p:nvSpPr>
         <p:spPr>
           <a:xfrm>
-            <a:off x="548640" y="3419856"/>
-            <a:ext cx="1234440" cy="283464"/>
-          </a:xfrm>
-          <a:prstGeom prst="rect">
-            <a:avLst/>
-          </a:prstGeom>
-          <a:noFill/>
-          <a:ln/>
-        </p:spPr>
-        <p:txBody>
-          <a:bodyPr wrap="square" lIns="0" tIns="0" rIns="0" bIns="0" rtlCol="0" anchor="t"/>
-          <a:lstStyle/>
-          <a:p>
-            <a:pPr algn="l" indent="0" marL="0">
-              <a:buNone/>
-            </a:pPr>
-            <a:r>
-              <a:rPr lang="en-US" sz="3000" b="1" dirty="0">
-                <a:solidFill>
-                  <a:srgbClr val="E8935A"/>
-                </a:solidFill>
-                <a:latin typeface="Georgia" pitchFamily="34" charset="0"/>
-                <a:ea typeface="Georgia" pitchFamily="34" charset="-122"/>
-                <a:cs typeface="Georgia" pitchFamily="34" charset="-120"/>
-              </a:rPr>
-              <a:t>60%</a:t>
-            </a:r>
-            <a:endParaRPr lang="en-US" sz="3000" dirty="0"/>
-          </a:p>
-        </p:txBody>
-      </p:sp>
-      <p:sp>
-        <p:nvSpPr>
-          <p:cNvPr id="18" name="Text 16"/>
-          <p:cNvSpPr txBox="1"/>
-          <p:nvPr/>
-        </p:nvSpPr>
-        <p:spPr>
-          <a:xfrm>
-            <a:off x="1828800" y="3447288"/>
-            <a:ext cx="4015588" cy="283464"/>
+            <a:off x="548640" y="2798064"/>
+            <a:ext cx="5029200" cy="475488"/>
           </a:xfrm>
           <a:prstGeom prst="rect">
             <a:avLst/>
@@ -1403,75 +1041,35 @@
           <a:p>
             <a:pPr algn="l" indent="0" marL="0">
               <a:lnSpc>
-                <a:spcPct val="105000"/>
+                <a:spcPct val="112000"/>
               </a:lnSpc>
               <a:buNone/>
             </a:pPr>
             <a:r>
-              <a:rPr lang="en-US" sz="1200" dirty="0">
+              <a:rPr lang="en-US" sz="1100" dirty="0">
                 <a:solidFill>
-                  <a:srgbClr val="F5F1E8"/>
+                  <a:srgbClr val="D0D0CE"/>
                 </a:solidFill>
                 <a:latin typeface="Calibri" pitchFamily="34" charset="0"/>
                 <a:ea typeface="Calibri" pitchFamily="34" charset="-122"/>
                 <a:cs typeface="Calibri" pitchFamily="34" charset="-120"/>
               </a:rPr>
-              <a:t>Lack of external industry participation</a:t>
-            </a:r>
-            <a:endParaRPr lang="en-US" sz="1200" dirty="0"/>
-          </a:p>
-        </p:txBody>
-      </p:sp>
-      <p:sp>
-        <p:nvSpPr>
-          <p:cNvPr id="19" name="Shape 17"/>
-          <p:cNvSpPr/>
-          <p:nvPr/>
-        </p:nvSpPr>
-        <p:spPr>
-          <a:xfrm>
-            <a:off x="548640" y="3730752"/>
-            <a:ext cx="5295748" cy="82296"/>
-          </a:xfrm>
-          <a:prstGeom prst="rect">
-            <a:avLst/>
-          </a:prstGeom>
-          <a:solidFill>
-            <a:srgbClr val="6B4A34"/>
-          </a:solidFill>
-          <a:ln/>
-        </p:spPr>
-      </p:sp>
-      <p:sp>
-        <p:nvSpPr>
-          <p:cNvPr id="20" name="Shape 18"/>
-          <p:cNvSpPr/>
-          <p:nvPr/>
-        </p:nvSpPr>
-        <p:spPr>
-          <a:xfrm>
-            <a:off x="548640" y="3730752"/>
-            <a:ext cx="3177449" cy="82296"/>
-          </a:xfrm>
-          <a:prstGeom prst="rect">
-            <a:avLst/>
-          </a:prstGeom>
-          <a:solidFill>
-            <a:srgbClr val="E8935A"/>
-          </a:solidFill>
-          <a:ln/>
-        </p:spPr>
-      </p:sp>
-      <p:sp>
-        <p:nvSpPr>
-          <p:cNvPr id="21" name="Text 19"/>
+              <a:t>average share citing STRUCTURAL barriers — data standardization, legal &amp; privacy rules, lack of external participation</a:t>
+            </a:r>
+            <a:endParaRPr lang="en-US" sz="1100" dirty="0"/>
+          </a:p>
+        </p:txBody>
+      </p:sp>
+      <p:sp>
+        <p:nvSpPr>
+          <p:cNvPr id="7" name="Text 5"/>
           <p:cNvSpPr txBox="1"/>
           <p:nvPr/>
         </p:nvSpPr>
         <p:spPr>
           <a:xfrm>
-            <a:off x="548640" y="3849624"/>
-            <a:ext cx="5295748" cy="329184"/>
+            <a:off x="5577840" y="2121408"/>
+            <a:ext cx="1036015" cy="365760"/>
           </a:xfrm>
           <a:prstGeom prst="rect">
             <a:avLst/>
@@ -1483,59 +1081,34 @@
           <a:bodyPr wrap="square" lIns="0" tIns="0" rIns="0" bIns="0" rtlCol="0" anchor="t"/>
           <a:lstStyle/>
           <a:p>
-            <a:pPr algn="l" indent="0" marL="0">
-              <a:lnSpc>
-                <a:spcPct val="115000"/>
-              </a:lnSpc>
+            <a:pPr algn="ctr" indent="0" marL="0">
               <a:buNone/>
             </a:pPr>
             <a:r>
-              <a:rPr lang="en-US" sz="950" i="1" dirty="0">
+              <a:rPr lang="en-US" sz="1600" i="1" dirty="0">
                 <a:solidFill>
-                  <a:srgbClr val="9AA5B1"/>
+                  <a:srgbClr val="8B9088"/>
                 </a:solidFill>
                 <a:latin typeface="Calibri" pitchFamily="34" charset="0"/>
                 <a:ea typeface="Calibri" pitchFamily="34" charset="-122"/>
                 <a:cs typeface="Calibri" pitchFamily="34" charset="-120"/>
               </a:rPr>
-              <a:t>Internal barriers trail far behind — governance (26%), ROI (27%), budget (36%). This isn't a problem of justifying information sharing internally.</a:t>
-            </a:r>
-            <a:endParaRPr lang="en-US" sz="950" dirty="0"/>
-          </a:p>
-        </p:txBody>
-      </p:sp>
-      <p:sp>
-        <p:nvSpPr>
-          <p:cNvPr id="22" name="Shape 20"/>
-          <p:cNvSpPr/>
-          <p:nvPr/>
-        </p:nvSpPr>
-        <p:spPr>
-          <a:xfrm>
-            <a:off x="6347308" y="1956816"/>
-            <a:ext cx="1554480" cy="292608"/>
-          </a:xfrm>
-          <a:prstGeom prst="roundRect">
-            <a:avLst>
-              <a:gd name="adj" fmla="val 50000"/>
-            </a:avLst>
-          </a:prstGeom>
-          <a:solidFill>
-            <a:srgbClr val="3FC1C9"/>
-          </a:solidFill>
-          <a:ln/>
-        </p:spPr>
-      </p:sp>
-      <p:sp>
-        <p:nvSpPr>
-          <p:cNvPr id="23" name="Text 21"/>
+              <a:t>vs</a:t>
+            </a:r>
+            <a:endParaRPr lang="en-US" sz="1600" dirty="0"/>
+          </a:p>
+        </p:txBody>
+      </p:sp>
+      <p:sp>
+        <p:nvSpPr>
+          <p:cNvPr id="8" name="Text 6"/>
           <p:cNvSpPr txBox="1"/>
           <p:nvPr/>
         </p:nvSpPr>
         <p:spPr>
           <a:xfrm>
-            <a:off x="6347308" y="1956816"/>
-            <a:ext cx="1554480" cy="292608"/>
+            <a:off x="6613855" y="1737360"/>
+            <a:ext cx="5029200" cy="1051560"/>
           </a:xfrm>
           <a:prstGeom prst="rect">
             <a:avLst/>
@@ -1544,76 +1117,37 @@
           <a:ln/>
         </p:spPr>
         <p:txBody>
-          <a:bodyPr wrap="square" lIns="0" tIns="0" rIns="0" bIns="0" rtlCol="0" anchor="ctr"/>
-          <a:lstStyle/>
-          <a:p>
-            <a:pPr algn="ctr" indent="0" marL="0">
+          <a:bodyPr wrap="square" lIns="0" tIns="0" rIns="0" bIns="0" rtlCol="0" anchor="t"/>
+          <a:lstStyle/>
+          <a:p>
+            <a:pPr algn="l" indent="0" marL="0">
               <a:buNone/>
             </a:pPr>
             <a:r>
-              <a:rPr lang="en-US" sz="1050" b="1" spc="100" kern="0" dirty="0">
+              <a:rPr lang="en-US" sz="6600" b="1" dirty="0">
                 <a:solidFill>
-                  <a:srgbClr val="0B1220"/>
+                  <a:srgbClr val="8B9088"/>
                 </a:solidFill>
                 <a:latin typeface="Calibri" pitchFamily="34" charset="0"/>
                 <a:ea typeface="Calibri" pitchFamily="34" charset="-122"/>
                 <a:cs typeface="Calibri" pitchFamily="34" charset="-120"/>
               </a:rPr>
-              <a:t>THE ANSWER</a:t>
-            </a:r>
-            <a:endParaRPr lang="en-US" sz="1050" dirty="0"/>
-          </a:p>
-        </p:txBody>
-      </p:sp>
-      <p:sp>
-        <p:nvSpPr>
-          <p:cNvPr id="24" name="Text 22"/>
+              <a:t>30%</a:t>
+            </a:r>
+            <a:endParaRPr lang="en-US" sz="6600" dirty="0"/>
+          </a:p>
+        </p:txBody>
+      </p:sp>
+      <p:sp>
+        <p:nvSpPr>
+          <p:cNvPr id="9" name="Text 7"/>
           <p:cNvSpPr txBox="1"/>
           <p:nvPr/>
         </p:nvSpPr>
         <p:spPr>
           <a:xfrm>
-            <a:off x="6347308" y="2340864"/>
-            <a:ext cx="1234440" cy="351495"/>
-          </a:xfrm>
-          <a:prstGeom prst="rect">
-            <a:avLst/>
-          </a:prstGeom>
-          <a:noFill/>
-          <a:ln/>
-        </p:spPr>
-        <p:txBody>
-          <a:bodyPr wrap="square" lIns="0" tIns="0" rIns="0" bIns="0" rtlCol="0" anchor="t"/>
-          <a:lstStyle/>
-          <a:p>
-            <a:pPr algn="l" indent="0" marL="0">
-              <a:buNone/>
-            </a:pPr>
-            <a:r>
-              <a:rPr lang="en-US" sz="3000" b="1" dirty="0">
-                <a:solidFill>
-                  <a:srgbClr val="3FC1C9"/>
-                </a:solidFill>
-                <a:latin typeface="Georgia" pitchFamily="34" charset="0"/>
-                <a:ea typeface="Georgia" pitchFamily="34" charset="-122"/>
-                <a:cs typeface="Georgia" pitchFamily="34" charset="-120"/>
-              </a:rPr>
-              <a:t>35%</a:t>
-            </a:r>
-            <a:endParaRPr lang="en-US" sz="3000" dirty="0"/>
-          </a:p>
-        </p:txBody>
-      </p:sp>
-      <p:sp>
-        <p:nvSpPr>
-          <p:cNvPr id="25" name="Text 23"/>
-          <p:cNvSpPr txBox="1"/>
-          <p:nvPr/>
-        </p:nvSpPr>
-        <p:spPr>
-          <a:xfrm>
-            <a:off x="7627468" y="2368296"/>
-            <a:ext cx="4015588" cy="351495"/>
+            <a:off x="6613855" y="2798064"/>
+            <a:ext cx="5029200" cy="475488"/>
           </a:xfrm>
           <a:prstGeom prst="rect">
             <a:avLst/>
@@ -1627,75 +1161,35 @@
           <a:p>
             <a:pPr algn="l" indent="0" marL="0">
               <a:lnSpc>
-                <a:spcPct val="105000"/>
+                <a:spcPct val="112000"/>
               </a:lnSpc>
               <a:buNone/>
             </a:pPr>
             <a:r>
-              <a:rPr lang="en-US" sz="1200" dirty="0">
+              <a:rPr lang="en-US" sz="1100" dirty="0">
                 <a:solidFill>
-                  <a:srgbClr val="F5F1E8"/>
+                  <a:srgbClr val="D0D0CE"/>
                 </a:solidFill>
                 <a:latin typeface="Calibri" pitchFamily="34" charset="0"/>
                 <a:ea typeface="Calibri" pitchFamily="34" charset="-122"/>
                 <a:cs typeface="Calibri" pitchFamily="34" charset="-120"/>
               </a:rPr>
-              <a:t>A centralized fraud information-sharing platform or utility</a:t>
-            </a:r>
-            <a:endParaRPr lang="en-US" sz="1200" dirty="0"/>
-          </a:p>
-        </p:txBody>
-      </p:sp>
-      <p:sp>
-        <p:nvSpPr>
-          <p:cNvPr id="26" name="Shape 24"/>
-          <p:cNvSpPr/>
-          <p:nvPr/>
-        </p:nvSpPr>
-        <p:spPr>
-          <a:xfrm>
-            <a:off x="6347308" y="2726375"/>
-            <a:ext cx="5295748" cy="82296"/>
-          </a:xfrm>
-          <a:prstGeom prst="rect">
-            <a:avLst/>
-          </a:prstGeom>
-          <a:solidFill>
-            <a:srgbClr val="1F4D50"/>
-          </a:solidFill>
-          <a:ln/>
-        </p:spPr>
-      </p:sp>
-      <p:sp>
-        <p:nvSpPr>
-          <p:cNvPr id="27" name="Shape 25"/>
-          <p:cNvSpPr/>
-          <p:nvPr/>
-        </p:nvSpPr>
-        <p:spPr>
-          <a:xfrm>
-            <a:off x="6347308" y="2726375"/>
-            <a:ext cx="1853512" cy="82296"/>
-          </a:xfrm>
-          <a:prstGeom prst="rect">
-            <a:avLst/>
-          </a:prstGeom>
-          <a:solidFill>
-            <a:srgbClr val="3FC1C9"/>
-          </a:solidFill>
-          <a:ln/>
-        </p:spPr>
-      </p:sp>
-      <p:sp>
-        <p:nvSpPr>
-          <p:cNvPr id="28" name="Text 26"/>
+              <a:t>average share citing INTERNAL barriers — unclear governance, difficulty proving ROI, insufficient budget</a:t>
+            </a:r>
+            <a:endParaRPr lang="en-US" sz="1100" dirty="0"/>
+          </a:p>
+        </p:txBody>
+      </p:sp>
+      <p:sp>
+        <p:nvSpPr>
+          <p:cNvPr id="10" name="Text 8"/>
           <p:cNvSpPr txBox="1"/>
           <p:nvPr/>
         </p:nvSpPr>
         <p:spPr>
           <a:xfrm>
-            <a:off x="6347308" y="3026664"/>
-            <a:ext cx="1234440" cy="351495"/>
+            <a:off x="548640" y="3328416"/>
+            <a:ext cx="11094415" cy="274320"/>
           </a:xfrm>
           <a:prstGeom prst="rect">
             <a:avLst/>
@@ -1711,112 +1205,30 @@
               <a:buNone/>
             </a:pPr>
             <a:r>
-              <a:rPr lang="en-US" sz="3000" b="1" dirty="0">
+              <a:rPr lang="en-US" sz="1250" i="1" dirty="0">
                 <a:solidFill>
-                  <a:srgbClr val="3FC1C9"/>
-                </a:solidFill>
-                <a:latin typeface="Georgia" pitchFamily="34" charset="0"/>
-                <a:ea typeface="Georgia" pitchFamily="34" charset="-122"/>
-                <a:cs typeface="Georgia" pitchFamily="34" charset="-120"/>
-              </a:rPr>
-              <a:t>26%</a:t>
-            </a:r>
-            <a:endParaRPr lang="en-US" sz="3000" dirty="0"/>
-          </a:p>
-        </p:txBody>
-      </p:sp>
-      <p:sp>
-        <p:nvSpPr>
-          <p:cNvPr id="29" name="Text 27"/>
-          <p:cNvSpPr txBox="1"/>
-          <p:nvPr/>
-        </p:nvSpPr>
-        <p:spPr>
-          <a:xfrm>
-            <a:off x="7627468" y="3054096"/>
-            <a:ext cx="4015588" cy="351495"/>
-          </a:xfrm>
-          <a:prstGeom prst="rect">
-            <a:avLst/>
-          </a:prstGeom>
-          <a:noFill/>
-          <a:ln/>
-        </p:spPr>
-        <p:txBody>
-          <a:bodyPr wrap="square" lIns="0" tIns="0" rIns="0" bIns="0" rtlCol="0" anchor="t"/>
-          <a:lstStyle/>
-          <a:p>
-            <a:pPr algn="l" indent="0" marL="0">
-              <a:lnSpc>
-                <a:spcPct val="105000"/>
-              </a:lnSpc>
-              <a:buNone/>
-            </a:pPr>
-            <a:r>
-              <a:rPr lang="en-US" sz="1200" dirty="0">
-                <a:solidFill>
-                  <a:srgbClr val="F5F1E8"/>
+                  <a:srgbClr val="FFFFFF"/>
                 </a:solidFill>
                 <a:latin typeface="Calibri" pitchFamily="34" charset="0"/>
                 <a:ea typeface="Calibri" pitchFamily="34" charset="-122"/>
                 <a:cs typeface="Calibri" pitchFamily="34" charset="-120"/>
               </a:rPr>
-              <a:t>Clearer legal &amp; regulatory frameworks</a:t>
-            </a:r>
-            <a:endParaRPr lang="en-US" sz="1200" dirty="0"/>
-          </a:p>
-        </p:txBody>
-      </p:sp>
-      <p:sp>
-        <p:nvSpPr>
-          <p:cNvPr id="30" name="Shape 28"/>
-          <p:cNvSpPr/>
-          <p:nvPr/>
-        </p:nvSpPr>
-        <p:spPr>
-          <a:xfrm>
-            <a:off x="6347308" y="3412175"/>
-            <a:ext cx="5295748" cy="82296"/>
-          </a:xfrm>
-          <a:prstGeom prst="rect">
-            <a:avLst/>
-          </a:prstGeom>
-          <a:solidFill>
-            <a:srgbClr val="1F4D50"/>
-          </a:solidFill>
-          <a:ln/>
-        </p:spPr>
-      </p:sp>
-      <p:sp>
-        <p:nvSpPr>
-          <p:cNvPr id="31" name="Shape 29"/>
-          <p:cNvSpPr/>
-          <p:nvPr/>
-        </p:nvSpPr>
-        <p:spPr>
-          <a:xfrm>
-            <a:off x="6347308" y="3412175"/>
-            <a:ext cx="1376894" cy="82296"/>
-          </a:xfrm>
-          <a:prstGeom prst="rect">
-            <a:avLst/>
-          </a:prstGeom>
-          <a:solidFill>
-            <a:srgbClr val="3FC1C9"/>
-          </a:solidFill>
-          <a:ln/>
-        </p:spPr>
-      </p:sp>
-      <p:sp>
-        <p:nvSpPr>
-          <p:cNvPr id="32" name="Text 30"/>
+              <a:t>The resistance isn't inside the building anymore — it's the space between institutions.</a:t>
+            </a:r>
+            <a:endParaRPr lang="en-US" sz="1250" dirty="0"/>
+          </a:p>
+        </p:txBody>
+      </p:sp>
+      <p:sp>
+        <p:nvSpPr>
+          <p:cNvPr id="11" name="Text 9"/>
           <p:cNvSpPr txBox="1"/>
           <p:nvPr/>
         </p:nvSpPr>
         <p:spPr>
           <a:xfrm>
-            <a:off x="6347308" y="3531047"/>
-            <a:ext cx="5295748" cy="329184"/>
+            <a:off x="548640" y="3694176"/>
+            <a:ext cx="11094415" cy="201168"/>
           </a:xfrm>
           <a:prstGeom prst="rect">
             <a:avLst/>
@@ -1829,78 +1241,75 @@
           <a:lstStyle/>
           <a:p>
             <a:pPr algn="l" indent="0" marL="0">
-              <a:lnSpc>
-                <a:spcPct val="115000"/>
-              </a:lnSpc>
               <a:buNone/>
             </a:pPr>
             <a:r>
-              <a:rPr lang="en-US" sz="950" i="1" dirty="0">
+              <a:rPr lang="en-US" sz="1050" b="1" spc="120" kern="0" dirty="0">
                 <a:solidFill>
-                  <a:srgbClr val="9AA5B1"/>
+                  <a:srgbClr val="43B02A"/>
                 </a:solidFill>
                 <a:latin typeface="Calibri" pitchFamily="34" charset="0"/>
                 <a:ea typeface="Calibri" pitchFamily="34" charset="-122"/>
                 <a:cs typeface="Calibri" pitchFamily="34" charset="-120"/>
               </a:rPr>
-              <a:t>The top fix mirrors the top barrier: leaders want infrastructure and certainty — not more encouragement to collaborate.</a:t>
-            </a:r>
-            <a:endParaRPr lang="en-US" sz="950" dirty="0"/>
-          </a:p>
-        </p:txBody>
-      </p:sp>
-      <p:sp>
-        <p:nvSpPr>
-          <p:cNvPr id="33" name="Shape 31"/>
+              <a:t>AND THE FIX MATCHES THE DIAGNOSIS</a:t>
+            </a:r>
+            <a:endParaRPr lang="en-US" sz="1050" dirty="0"/>
+          </a:p>
+        </p:txBody>
+      </p:sp>
+      <p:sp>
+        <p:nvSpPr>
+          <p:cNvPr id="12" name="Shape 10"/>
           <p:cNvSpPr/>
           <p:nvPr/>
         </p:nvSpPr>
         <p:spPr>
           <a:xfrm>
-            <a:off x="548640" y="4434840"/>
-            <a:ext cx="5295748" cy="1600200"/>
+            <a:off x="548640" y="3986784"/>
+            <a:ext cx="5410048" cy="566928"/>
           </a:xfrm>
           <a:prstGeom prst="roundRect">
             <a:avLst>
-              <a:gd name="adj" fmla="val 4000"/>
+              <a:gd name="adj" fmla="val 8065"/>
             </a:avLst>
           </a:prstGeom>
           <a:solidFill>
-            <a:srgbClr val="141B2E"/>
-          </a:solidFill>
-          <a:ln/>
-        </p:spPr>
-      </p:sp>
-      <p:sp>
-        <p:nvSpPr>
-          <p:cNvPr id="34" name="Shape 32"/>
+            <a:srgbClr val="10160D"/>
+          </a:solidFill>
+          <a:ln/>
+        </p:spPr>
+      </p:sp>
+      <p:sp>
+        <p:nvSpPr>
+          <p:cNvPr id="13" name="Shape 11"/>
           <p:cNvSpPr/>
           <p:nvPr/>
         </p:nvSpPr>
         <p:spPr>
           <a:xfrm>
-            <a:off x="548640" y="4434840"/>
-            <a:ext cx="54864" cy="1600200"/>
-          </a:xfrm>
-          <a:prstGeom prst="rect">
-            <a:avLst/>
-          </a:prstGeom>
-          <a:solidFill>
-            <a:srgbClr val="E8935A"/>
-          </a:solidFill>
-          <a:ln/>
-        </p:spPr>
-      </p:sp>
-      <p:sp>
-        <p:nvSpPr>
-          <p:cNvPr id="35" name="Text 33"/>
+            <a:off x="548640" y="3986784"/>
+            <a:ext cx="54864" cy="566928"/>
+          </a:xfrm>
+          <a:prstGeom prst="rect">
+            <a:avLst/>
+          </a:prstGeom>
+          <a:solidFill>
+            <a:srgbClr val="86BC25"/>
+          </a:solidFill>
+          <a:ln/>
+        </p:spPr>
+      </p:sp>
+      <p:sp>
+        <p:nvSpPr>
+          <p:cNvPr id="14" name="Text 12"/>
           <p:cNvSpPr txBox="1"/>
           <p:nvPr/>
         </p:nvSpPr>
         <p:spPr>
           <a:xfrm>
-            <a:off x="804672" y="4562856"/>
-            <a:ext cx="4838548" cy="201168"/>
+            <a:off x="749808" y="4078224"/>
+            <a:ext cx="1051560" cy="384048"/>
           </a:xfrm>
           <a:prstGeom prst="rect">
             <a:avLst/>
@@ -1909,37 +1318,37 @@
           <a:ln/>
         </p:spPr>
         <p:txBody>
-          <a:bodyPr wrap="square" lIns="0" tIns="0" rIns="0" bIns="0" rtlCol="0" anchor="t"/>
+          <a:bodyPr wrap="square" lIns="0" tIns="0" rIns="0" bIns="0" rtlCol="0" anchor="ctr"/>
           <a:lstStyle/>
           <a:p>
             <a:pPr algn="l" indent="0" marL="0">
               <a:buNone/>
             </a:pPr>
             <a:r>
-              <a:rPr lang="en-US" sz="950" b="1" spc="150" kern="0" dirty="0">
+              <a:rPr lang="en-US" sz="2600" b="1" dirty="0">
                 <a:solidFill>
-                  <a:srgbClr val="E8935A"/>
+                  <a:srgbClr val="86BC25"/>
                 </a:solidFill>
                 <a:latin typeface="Calibri" pitchFamily="34" charset="0"/>
                 <a:ea typeface="Calibri" pitchFamily="34" charset="-122"/>
                 <a:cs typeface="Calibri" pitchFamily="34" charset="-120"/>
               </a:rPr>
-              <a:t>REGIONAL LENS</a:t>
-            </a:r>
-            <a:endParaRPr lang="en-US" sz="950" dirty="0"/>
-          </a:p>
-        </p:txBody>
-      </p:sp>
-      <p:sp>
-        <p:nvSpPr>
-          <p:cNvPr id="36" name="Text 34"/>
+              <a:t>35%</a:t>
+            </a:r>
+            <a:endParaRPr lang="en-US" sz="2600" dirty="0"/>
+          </a:p>
+        </p:txBody>
+      </p:sp>
+      <p:sp>
+        <p:nvSpPr>
+          <p:cNvPr id="15" name="Text 13"/>
           <p:cNvSpPr txBox="1"/>
           <p:nvPr/>
         </p:nvSpPr>
         <p:spPr>
           <a:xfrm>
-            <a:off x="804672" y="4773168"/>
-            <a:ext cx="4838548" cy="292608"/>
+            <a:off x="1783080" y="4078224"/>
+            <a:ext cx="3992728" cy="384048"/>
           </a:xfrm>
           <a:prstGeom prst="rect">
             <a:avLst/>
@@ -1948,121 +1357,82 @@
           <a:ln/>
         </p:spPr>
         <p:txBody>
-          <a:bodyPr wrap="square" lIns="0" tIns="0" rIns="0" bIns="0" rtlCol="0" anchor="t"/>
-          <a:lstStyle/>
-          <a:p>
-            <a:pPr algn="l" indent="0" marL="0">
-              <a:buNone/>
-            </a:pPr>
-            <a:r>
-              <a:rPr lang="en-US" sz="1500" b="1" dirty="0">
-                <a:solidFill>
-                  <a:srgbClr val="F5F1E8"/>
-                </a:solidFill>
-                <a:latin typeface="Georgia" pitchFamily="34" charset="0"/>
-                <a:ea typeface="Georgia" pitchFamily="34" charset="-122"/>
-                <a:cs typeface="Georgia" pitchFamily="34" charset="-120"/>
-              </a:rPr>
-              <a:t>Australia sees it differently</a:t>
-            </a:r>
-            <a:endParaRPr lang="en-US" sz="1500" dirty="0"/>
-          </a:p>
-        </p:txBody>
-      </p:sp>
-      <p:sp>
-        <p:nvSpPr>
-          <p:cNvPr id="37" name="Text 35"/>
-          <p:cNvSpPr txBox="1"/>
-          <p:nvPr/>
-        </p:nvSpPr>
-        <p:spPr>
-          <a:xfrm>
-            <a:off x="804672" y="5074920"/>
-            <a:ext cx="4838548" cy="850392"/>
-          </a:xfrm>
-          <a:prstGeom prst="rect">
-            <a:avLst/>
-          </a:prstGeom>
-          <a:noFill/>
-          <a:ln/>
-        </p:spPr>
-        <p:txBody>
-          <a:bodyPr wrap="square" lIns="0" tIns="0" rIns="0" bIns="0" rtlCol="0" anchor="t"/>
+          <a:bodyPr wrap="square" lIns="0" tIns="0" rIns="0" bIns="0" rtlCol="0" anchor="ctr"/>
           <a:lstStyle/>
           <a:p>
             <a:pPr algn="l" indent="0" marL="0">
               <a:lnSpc>
-                <a:spcPct val="118000"/>
+                <a:spcPct val="108000"/>
               </a:lnSpc>
               <a:buNone/>
             </a:pPr>
             <a:r>
-              <a:rPr lang="en-US" sz="1000" dirty="0">
+              <a:rPr lang="en-US" sz="1100" dirty="0">
                 <a:solidFill>
-                  <a:srgbClr val="9AA5B1"/>
+                  <a:srgbClr val="FFFFFF"/>
                 </a:solidFill>
                 <a:latin typeface="Calibri" pitchFamily="34" charset="0"/>
                 <a:ea typeface="Calibri" pitchFamily="34" charset="-122"/>
                 <a:cs typeface="Calibri" pitchFamily="34" charset="-120"/>
               </a:rPr>
-              <a:t>Only 43% cite lack of participation as a barrier — vs. 74% in the U.S. and 61% in Canada — pointing to an infrastructure and data-quality problem, not a participation one. Canadian insurers uniquely flag unclear governance and ownership.</a:t>
-            </a:r>
-            <a:endParaRPr lang="en-US" sz="1000" dirty="0"/>
-          </a:p>
-        </p:txBody>
-      </p:sp>
-      <p:sp>
-        <p:nvSpPr>
-          <p:cNvPr id="38" name="Shape 36"/>
+              <a:t>want a centralized fraud information-sharing platform or utility</a:t>
+            </a:r>
+            <a:endParaRPr lang="en-US" sz="1100" dirty="0"/>
+          </a:p>
+        </p:txBody>
+      </p:sp>
+      <p:sp>
+        <p:nvSpPr>
+          <p:cNvPr id="16" name="Shape 14"/>
           <p:cNvSpPr/>
           <p:nvPr/>
         </p:nvSpPr>
         <p:spPr>
           <a:xfrm>
-            <a:off x="6347308" y="4434840"/>
-            <a:ext cx="5295748" cy="1600200"/>
+            <a:off x="6233008" y="3986784"/>
+            <a:ext cx="5410048" cy="566928"/>
           </a:xfrm>
           <a:prstGeom prst="roundRect">
             <a:avLst>
-              <a:gd name="adj" fmla="val 4000"/>
+              <a:gd name="adj" fmla="val 8065"/>
             </a:avLst>
           </a:prstGeom>
           <a:solidFill>
-            <a:srgbClr val="141B2E"/>
-          </a:solidFill>
-          <a:ln/>
-        </p:spPr>
-      </p:sp>
-      <p:sp>
-        <p:nvSpPr>
-          <p:cNvPr id="39" name="Shape 37"/>
+            <a:srgbClr val="10160D"/>
+          </a:solidFill>
+          <a:ln/>
+        </p:spPr>
+      </p:sp>
+      <p:sp>
+        <p:nvSpPr>
+          <p:cNvPr id="17" name="Shape 15"/>
           <p:cNvSpPr/>
           <p:nvPr/>
         </p:nvSpPr>
         <p:spPr>
           <a:xfrm>
-            <a:off x="6347308" y="4434840"/>
-            <a:ext cx="54864" cy="1600200"/>
-          </a:xfrm>
-          <a:prstGeom prst="rect">
-            <a:avLst/>
-          </a:prstGeom>
-          <a:solidFill>
-            <a:srgbClr val="3FC1C9"/>
-          </a:solidFill>
-          <a:ln/>
-        </p:spPr>
-      </p:sp>
-      <p:sp>
-        <p:nvSpPr>
-          <p:cNvPr id="40" name="Text 38"/>
+            <a:off x="6233008" y="3986784"/>
+            <a:ext cx="54864" cy="566928"/>
+          </a:xfrm>
+          <a:prstGeom prst="rect">
+            <a:avLst/>
+          </a:prstGeom>
+          <a:solidFill>
+            <a:srgbClr val="86BC25"/>
+          </a:solidFill>
+          <a:ln/>
+        </p:spPr>
+      </p:sp>
+      <p:sp>
+        <p:nvSpPr>
+          <p:cNvPr id="18" name="Text 16"/>
           <p:cNvSpPr txBox="1"/>
           <p:nvPr/>
         </p:nvSpPr>
         <p:spPr>
           <a:xfrm>
-            <a:off x="6603340" y="4562856"/>
-            <a:ext cx="4838548" cy="201168"/>
+            <a:off x="6434176" y="4078224"/>
+            <a:ext cx="1051560" cy="384048"/>
           </a:xfrm>
           <a:prstGeom prst="rect">
             <a:avLst/>
@@ -2071,37 +1441,37 @@
           <a:ln/>
         </p:spPr>
         <p:txBody>
-          <a:bodyPr wrap="square" lIns="0" tIns="0" rIns="0" bIns="0" rtlCol="0" anchor="t"/>
+          <a:bodyPr wrap="square" lIns="0" tIns="0" rIns="0" bIns="0" rtlCol="0" anchor="ctr"/>
           <a:lstStyle/>
           <a:p>
             <a:pPr algn="l" indent="0" marL="0">
               <a:buNone/>
             </a:pPr>
             <a:r>
-              <a:rPr lang="en-US" sz="950" b="1" spc="150" kern="0" dirty="0">
+              <a:rPr lang="en-US" sz="2600" b="1" dirty="0">
                 <a:solidFill>
-                  <a:srgbClr val="3FC1C9"/>
+                  <a:srgbClr val="86BC25"/>
                 </a:solidFill>
                 <a:latin typeface="Calibri" pitchFamily="34" charset="0"/>
                 <a:ea typeface="Calibri" pitchFamily="34" charset="-122"/>
                 <a:cs typeface="Calibri" pitchFamily="34" charset="-120"/>
               </a:rPr>
-              <a:t>REGIONAL LENS</a:t>
-            </a:r>
-            <a:endParaRPr lang="en-US" sz="950" dirty="0"/>
-          </a:p>
-        </p:txBody>
-      </p:sp>
-      <p:sp>
-        <p:nvSpPr>
-          <p:cNvPr id="41" name="Text 39"/>
+              <a:t>26%</a:t>
+            </a:r>
+            <a:endParaRPr lang="en-US" sz="2600" dirty="0"/>
+          </a:p>
+        </p:txBody>
+      </p:sp>
+      <p:sp>
+        <p:nvSpPr>
+          <p:cNvPr id="19" name="Text 17"/>
           <p:cNvSpPr txBox="1"/>
           <p:nvPr/>
         </p:nvSpPr>
         <p:spPr>
           <a:xfrm>
-            <a:off x="6603340" y="4773168"/>
-            <a:ext cx="4838548" cy="292608"/>
+            <a:off x="7467448" y="4078224"/>
+            <a:ext cx="3992728" cy="384048"/>
           </a:xfrm>
           <a:prstGeom prst="rect">
             <a:avLst/>
@@ -2110,64 +1480,64 @@
           <a:ln/>
         </p:spPr>
         <p:txBody>
-          <a:bodyPr wrap="square" lIns="0" tIns="0" rIns="0" bIns="0" rtlCol="0" anchor="t"/>
-          <a:lstStyle/>
-          <a:p>
-            <a:pPr algn="l" indent="0" marL="0">
-              <a:buNone/>
-            </a:pPr>
-            <a:r>
-              <a:rPr lang="en-US" sz="1500" b="1" dirty="0">
-                <a:solidFill>
-                  <a:srgbClr val="F5F1E8"/>
-                </a:solidFill>
-                <a:latin typeface="Georgia" pitchFamily="34" charset="0"/>
-                <a:ea typeface="Georgia" pitchFamily="34" charset="-122"/>
-                <a:cs typeface="Georgia" pitchFamily="34" charset="-120"/>
-              </a:rPr>
-              <a:t>The U.S. breaks the pattern</a:t>
-            </a:r>
-            <a:endParaRPr lang="en-US" sz="1500" dirty="0"/>
-          </a:p>
-        </p:txBody>
-      </p:sp>
-      <p:sp>
-        <p:nvSpPr>
-          <p:cNvPr id="42" name="Text 40"/>
-          <p:cNvSpPr txBox="1"/>
-          <p:nvPr/>
-        </p:nvSpPr>
-        <p:spPr>
-          <a:xfrm>
-            <a:off x="6603340" y="5074920"/>
-            <a:ext cx="4838548" cy="850392"/>
-          </a:xfrm>
-          <a:prstGeom prst="rect">
-            <a:avLst/>
-          </a:prstGeom>
-          <a:noFill/>
-          <a:ln/>
-        </p:spPr>
-        <p:txBody>
-          <a:bodyPr wrap="square" lIns="0" tIns="0" rIns="0" bIns="0" rtlCol="0" anchor="t"/>
+          <a:bodyPr wrap="square" lIns="0" tIns="0" rIns="0" bIns="0" rtlCol="0" anchor="ctr"/>
           <a:lstStyle/>
           <a:p>
             <a:pPr algn="l" indent="0" marL="0">
               <a:lnSpc>
-                <a:spcPct val="118000"/>
+                <a:spcPct val="108000"/>
               </a:lnSpc>
               <a:buNone/>
             </a:pPr>
             <a:r>
-              <a:rPr lang="en-US" sz="1000" dirty="0">
+              <a:rPr lang="en-US" sz="1100" dirty="0">
                 <a:solidFill>
-                  <a:srgbClr val="9AA5B1"/>
+                  <a:srgbClr val="FFFFFF"/>
                 </a:solidFill>
                 <a:latin typeface="Calibri" pitchFamily="34" charset="0"/>
                 <a:ea typeface="Calibri" pitchFamily="34" charset="-122"/>
                 <a:cs typeface="Calibri" pitchFamily="34" charset="-120"/>
               </a:rPr>
-              <a:t>America ranks platform infrastructure first, then public-private collaboration — the only market that doesn't prioritize regulatory reform. Australia shows the weakest support of any market for a centralized utility.</a:t>
+              <a:t>want clearer legal &amp; regulatory frameworks</a:t>
+            </a:r>
+            <a:endParaRPr lang="en-US" sz="1100" dirty="0"/>
+          </a:p>
+        </p:txBody>
+      </p:sp>
+      <p:sp>
+        <p:nvSpPr>
+          <p:cNvPr id="20" name="Text 18"/>
+          <p:cNvSpPr txBox="1"/>
+          <p:nvPr/>
+        </p:nvSpPr>
+        <p:spPr>
+          <a:xfrm>
+            <a:off x="548640" y="4645152"/>
+            <a:ext cx="11094415" cy="237744"/>
+          </a:xfrm>
+          <a:prstGeom prst="rect">
+            <a:avLst/>
+          </a:prstGeom>
+          <a:noFill/>
+          <a:ln/>
+        </p:spPr>
+        <p:txBody>
+          <a:bodyPr wrap="square" lIns="0" tIns="0" rIns="0" bIns="0" rtlCol="0" anchor="t"/>
+          <a:lstStyle/>
+          <a:p>
+            <a:pPr algn="l" indent="0" marL="0">
+              <a:buNone/>
+            </a:pPr>
+            <a:r>
+              <a:rPr lang="en-US" sz="1000" i="1" dirty="0">
+                <a:solidFill>
+                  <a:srgbClr val="D0D0CE"/>
+                </a:solidFill>
+                <a:latin typeface="Calibri" pitchFamily="34" charset="0"/>
+                <a:ea typeface="Calibri" pitchFamily="34" charset="-122"/>
+                <a:cs typeface="Calibri" pitchFamily="34" charset="-120"/>
+              </a:rPr>
+              <a:t>The two most-requested fixes map directly onto the two most structural barriers.</a:t>
             </a:r>
             <a:endParaRPr lang="en-US" sz="1000" dirty="0"/>
           </a:p>
@@ -2175,13 +1545,289 @@
       </p:sp>
       <p:sp>
         <p:nvSpPr>
-          <p:cNvPr id="43" name="Shape 41"/>
+          <p:cNvPr id="21" name="Text 19"/>
+          <p:cNvSpPr txBox="1"/>
+          <p:nvPr/>
+        </p:nvSpPr>
+        <p:spPr>
+          <a:xfrm>
+            <a:off x="548640" y="4992624"/>
+            <a:ext cx="11094415" cy="201168"/>
+          </a:xfrm>
+          <a:prstGeom prst="rect">
+            <a:avLst/>
+          </a:prstGeom>
+          <a:noFill/>
+          <a:ln/>
+        </p:spPr>
+        <p:txBody>
+          <a:bodyPr wrap="square" lIns="0" tIns="0" rIns="0" bIns="0" rtlCol="0" anchor="t"/>
+          <a:lstStyle/>
+          <a:p>
+            <a:pPr algn="l" indent="0" marL="0">
+              <a:buNone/>
+            </a:pPr>
+            <a:r>
+              <a:rPr lang="en-US" sz="1050" b="1" spc="120" kern="0" dirty="0">
+                <a:solidFill>
+                  <a:srgbClr val="43B02A"/>
+                </a:solidFill>
+                <a:latin typeface="Calibri" pitchFamily="34" charset="0"/>
+                <a:ea typeface="Calibri" pitchFamily="34" charset="-122"/>
+                <a:cs typeface="Calibri" pitchFamily="34" charset="-120"/>
+              </a:rPr>
+              <a:t>BUT THE DIAGNOSIS ISN'T UNIVERSAL</a:t>
+            </a:r>
+            <a:endParaRPr lang="en-US" sz="1050" dirty="0"/>
+          </a:p>
+        </p:txBody>
+      </p:sp>
+      <p:sp>
+        <p:nvSpPr>
+          <p:cNvPr id="22" name="Shape 20"/>
           <p:cNvSpPr/>
           <p:nvPr/>
         </p:nvSpPr>
         <p:spPr>
           <a:xfrm>
-            <a:off x="548640" y="6419088"/>
+            <a:off x="548640" y="5321808"/>
+            <a:ext cx="82296" cy="274320"/>
+          </a:xfrm>
+          <a:prstGeom prst="rect">
+            <a:avLst/>
+          </a:prstGeom>
+          <a:solidFill>
+            <a:srgbClr val="86BC25"/>
+          </a:solidFill>
+          <a:ln/>
+        </p:spPr>
+      </p:sp>
+      <p:sp>
+        <p:nvSpPr>
+          <p:cNvPr id="23" name="Text 21"/>
+          <p:cNvSpPr txBox="1"/>
+          <p:nvPr/>
+        </p:nvSpPr>
+        <p:spPr>
+          <a:xfrm>
+            <a:off x="749808" y="5285232"/>
+            <a:ext cx="10893247" cy="402336"/>
+          </a:xfrm>
+          <a:prstGeom prst="rect">
+            <a:avLst/>
+          </a:prstGeom>
+          <a:noFill/>
+          <a:ln/>
+        </p:spPr>
+        <p:txBody>
+          <a:bodyPr wrap="square" lIns="0" tIns="0" rIns="0" bIns="0" rtlCol="0" anchor="t"/>
+          <a:lstStyle/>
+          <a:p>
+            <a:pPr algn="l" indent="0" marL="0">
+              <a:lnSpc>
+                <a:spcPct val="112000"/>
+              </a:lnSpc>
+              <a:buNone/>
+            </a:pPr>
+            <a:r>
+              <a:rPr lang="en-US" sz="1100" b="1" dirty="0">
+                <a:solidFill>
+                  <a:srgbClr val="FFFFFF"/>
+                </a:solidFill>
+                <a:latin typeface="Calibri" pitchFamily="34" charset="0"/>
+                <a:ea typeface="Calibri" pitchFamily="34" charset="-122"/>
+                <a:cs typeface="Calibri" pitchFamily="34" charset="-120"/>
+              </a:rPr>
+              <a:t>Australia reads it differently.  </a:t>
+            </a:r>
+            <a:pPr algn="l" indent="0" marL="0">
+              <a:lnSpc>
+                <a:spcPct val="112000"/>
+              </a:lnSpc>
+              <a:buNone/>
+            </a:pPr>
+            <a:r>
+              <a:rPr lang="en-US" sz="1100" dirty="0">
+                <a:solidFill>
+                  <a:srgbClr val="D0D0CE"/>
+                </a:solidFill>
+                <a:latin typeface="Calibri" pitchFamily="34" charset="0"/>
+                <a:ea typeface="Calibri" pitchFamily="34" charset="-122"/>
+                <a:cs typeface="Calibri" pitchFamily="34" charset="-120"/>
+              </a:rPr>
+              <a:t>Only 43% flag lack of participation as a barrier, vs. 74% in the U.S. and 61% in Canada — pointing to an infrastructure and data-quality problem, not a willingness one.</a:t>
+            </a:r>
+            <a:endParaRPr lang="en-US" sz="1100" dirty="0"/>
+          </a:p>
+        </p:txBody>
+      </p:sp>
+      <p:sp>
+        <p:nvSpPr>
+          <p:cNvPr id="24" name="Shape 22"/>
+          <p:cNvSpPr/>
+          <p:nvPr/>
+        </p:nvSpPr>
+        <p:spPr>
+          <a:xfrm>
+            <a:off x="548640" y="5724144"/>
+            <a:ext cx="82296" cy="274320"/>
+          </a:xfrm>
+          <a:prstGeom prst="rect">
+            <a:avLst/>
+          </a:prstGeom>
+          <a:solidFill>
+            <a:srgbClr val="86BC25"/>
+          </a:solidFill>
+          <a:ln/>
+        </p:spPr>
+      </p:sp>
+      <p:sp>
+        <p:nvSpPr>
+          <p:cNvPr id="25" name="Text 23"/>
+          <p:cNvSpPr txBox="1"/>
+          <p:nvPr/>
+        </p:nvSpPr>
+        <p:spPr>
+          <a:xfrm>
+            <a:off x="749808" y="5687568"/>
+            <a:ext cx="10893247" cy="402336"/>
+          </a:xfrm>
+          <a:prstGeom prst="rect">
+            <a:avLst/>
+          </a:prstGeom>
+          <a:noFill/>
+          <a:ln/>
+        </p:spPr>
+        <p:txBody>
+          <a:bodyPr wrap="square" lIns="0" tIns="0" rIns="0" bIns="0" rtlCol="0" anchor="t"/>
+          <a:lstStyle/>
+          <a:p>
+            <a:pPr algn="l" indent="0" marL="0">
+              <a:lnSpc>
+                <a:spcPct val="112000"/>
+              </a:lnSpc>
+              <a:buNone/>
+            </a:pPr>
+            <a:r>
+              <a:rPr lang="en-US" sz="1100" b="1" dirty="0">
+                <a:solidFill>
+                  <a:srgbClr val="FFFFFF"/>
+                </a:solidFill>
+                <a:latin typeface="Calibri" pitchFamily="34" charset="0"/>
+                <a:ea typeface="Calibri" pitchFamily="34" charset="-122"/>
+                <a:cs typeface="Calibri" pitchFamily="34" charset="-120"/>
+              </a:rPr>
+              <a:t>Canadian insurers flag something no one else does.  </a:t>
+            </a:r>
+            <a:pPr algn="l" indent="0" marL="0">
+              <a:lnSpc>
+                <a:spcPct val="112000"/>
+              </a:lnSpc>
+              <a:buNone/>
+            </a:pPr>
+            <a:r>
+              <a:rPr lang="en-US" sz="1100" dirty="0">
+                <a:solidFill>
+                  <a:srgbClr val="D0D0CE"/>
+                </a:solidFill>
+                <a:latin typeface="Calibri" pitchFamily="34" charset="0"/>
+                <a:ea typeface="Calibri" pitchFamily="34" charset="-122"/>
+                <a:cs typeface="Calibri" pitchFamily="34" charset="-120"/>
+              </a:rPr>
+              <a:t>Unclear governance and ownership rank unusually high there — accountability, not appetite, is what's unresolved.</a:t>
+            </a:r>
+            <a:endParaRPr lang="en-US" sz="1100" dirty="0"/>
+          </a:p>
+        </p:txBody>
+      </p:sp>
+      <p:sp>
+        <p:nvSpPr>
+          <p:cNvPr id="26" name="Shape 24"/>
+          <p:cNvSpPr/>
+          <p:nvPr/>
+        </p:nvSpPr>
+        <p:spPr>
+          <a:xfrm>
+            <a:off x="548640" y="6126480"/>
+            <a:ext cx="82296" cy="274320"/>
+          </a:xfrm>
+          <a:prstGeom prst="rect">
+            <a:avLst/>
+          </a:prstGeom>
+          <a:solidFill>
+            <a:srgbClr val="86BC25"/>
+          </a:solidFill>
+          <a:ln/>
+        </p:spPr>
+      </p:sp>
+      <p:sp>
+        <p:nvSpPr>
+          <p:cNvPr id="27" name="Text 25"/>
+          <p:cNvSpPr txBox="1"/>
+          <p:nvPr/>
+        </p:nvSpPr>
+        <p:spPr>
+          <a:xfrm>
+            <a:off x="749808" y="6089904"/>
+            <a:ext cx="10893247" cy="402336"/>
+          </a:xfrm>
+          <a:prstGeom prst="rect">
+            <a:avLst/>
+          </a:prstGeom>
+          <a:noFill/>
+          <a:ln/>
+        </p:spPr>
+        <p:txBody>
+          <a:bodyPr wrap="square" lIns="0" tIns="0" rIns="0" bIns="0" rtlCol="0" anchor="t"/>
+          <a:lstStyle/>
+          <a:p>
+            <a:pPr algn="l" indent="0" marL="0">
+              <a:lnSpc>
+                <a:spcPct val="112000"/>
+              </a:lnSpc>
+              <a:buNone/>
+            </a:pPr>
+            <a:r>
+              <a:rPr lang="en-US" sz="1100" b="1" dirty="0">
+                <a:solidFill>
+                  <a:srgbClr val="FFFFFF"/>
+                </a:solidFill>
+                <a:latin typeface="Calibri" pitchFamily="34" charset="0"/>
+                <a:ea typeface="Calibri" pitchFamily="34" charset="-122"/>
+                <a:cs typeface="Calibri" pitchFamily="34" charset="-120"/>
+              </a:rPr>
+              <a:t>The U.S. skips regulatory reform entirely.  </a:t>
+            </a:r>
+            <a:pPr algn="l" indent="0" marL="0">
+              <a:lnSpc>
+                <a:spcPct val="112000"/>
+              </a:lnSpc>
+              <a:buNone/>
+            </a:pPr>
+            <a:r>
+              <a:rPr lang="en-US" sz="1100" dirty="0">
+                <a:solidFill>
+                  <a:srgbClr val="D0D0CE"/>
+                </a:solidFill>
+                <a:latin typeface="Calibri" pitchFamily="34" charset="0"/>
+                <a:ea typeface="Calibri" pitchFamily="34" charset="-122"/>
+                <a:cs typeface="Calibri" pitchFamily="34" charset="-120"/>
+              </a:rPr>
+              <a:t>It's the only market that doesn't rank clearer legal frameworks among its top fixes, leaning instead on platform infrastructure and public-private collaboration.</a:t>
+            </a:r>
+            <a:endParaRPr lang="en-US" sz="1100" dirty="0"/>
+          </a:p>
+        </p:txBody>
+      </p:sp>
+      <p:sp>
+        <p:nvSpPr>
+          <p:cNvPr id="28" name="Shape 26"/>
+          <p:cNvSpPr/>
+          <p:nvPr/>
+        </p:nvSpPr>
+        <p:spPr>
+          <a:xfrm>
+            <a:off x="548640" y="6537960"/>
             <a:ext cx="11094415" cy="0"/>
           </a:xfrm>
           <a:prstGeom prst="line">
@@ -2190,7 +1836,7 @@
           <a:noFill/>
           <a:ln w="9525">
             <a:solidFill>
-              <a:srgbClr val="263248"/>
+              <a:srgbClr val="1C2419"/>
             </a:solidFill>
             <a:prstDash val="solid"/>
           </a:ln>
@@ -2198,14 +1844,14 @@
       </p:sp>
       <p:sp>
         <p:nvSpPr>
-          <p:cNvPr id="44" name="Text 42"/>
+          <p:cNvPr id="29" name="Text 27"/>
           <p:cNvSpPr txBox="1"/>
           <p:nvPr/>
         </p:nvSpPr>
         <p:spPr>
           <a:xfrm>
-            <a:off x="548640" y="6473952"/>
-            <a:ext cx="11094415" cy="274320"/>
+            <a:off x="548640" y="6592824"/>
+            <a:ext cx="11094415" cy="219456"/>
           </a:xfrm>
           <a:prstGeom prst="rect">
             <a:avLst/>
@@ -2221,9 +1867,9 @@
               <a:buNone/>
             </a:pPr>
             <a:r>
-              <a:rPr lang="en-US" sz="850" dirty="0">
+              <a:rPr lang="en-US" sz="850" i="1" dirty="0">
                 <a:solidFill>
-                  <a:srgbClr val="9AA5B1"/>
+                  <a:srgbClr val="8B9088"/>
                 </a:solidFill>
                 <a:latin typeface="Calibri" pitchFamily="34" charset="0"/>
                 <a:ea typeface="Calibri" pitchFamily="34" charset="-122"/>

</xml_diff>